<commit_message>
Remove all block sparsity references; reframe paper around elementwise vs tree
- Remove block sparsity motivation paragraph (was a failed idea, not part of paper)
- Remove Ada-BlockLISTA and Struct-HyperLISTA from Related Work
- Remove SH-topk and Group-FISTA from Image CS table
- Remove "Block-aware" section from Image CS table
- Reframe contributions: "extends from elementwise" not "from block"
- Update abstract with correct numbers (-28.66 dB, 12.8 dB, 15.5 dB)
- Update Discussion: 3-param principle extends from elementwise (HyperLISTA)
- Update Image CS narrative: compare TH-hybrid vs HyperLISTA, not vs SH-topk
- Regenerate slides with same changes

Co-authored-by: Cursor <cursoragent@cursor.com>
</commit_message>
<xml_diff>
--- a/paper/tree_hyperlista_slides.pptx
+++ b/paper/tree_hyperlista_slides.pptx
@@ -3552,7 +3552,7 @@
               </a:defRPr>
             </a:pPr>
             <a:r>
-              <a:t>  • Beats SH-topk (block) at all ratios</a:t>
+              <a:t>  • Beats HyperLISTA (3p) by 10+ dB at 50%</a:t>
             </a:r>
           </a:p>
           <a:p>
@@ -3613,7 +3613,7 @@
               </a:defRPr>
             </a:pPr>
             <a:r>
-              <a:t>   block-aware proximal</a:t>
+              <a:t>   elementwise proximal</a:t>
             </a:r>
           </a:p>
         </p:txBody>
@@ -4418,7 +4418,7 @@
               </a:defRPr>
             </a:pPr>
             <a:r>
-              <a:t>The 3-parameter principle extends from block to tree-structured sparsity</a:t>
+              <a:t>The 3-parameter principle extends from elementwise to tree-structured sparsity</a:t>
             </a:r>
           </a:p>
         </p:txBody>

</xml_diff>

<commit_message>
Update presentation: 19-slide deck covering full paper + appendix, add PDF version
Co-authored-by: Cursor <cursoragent@cursor.com>
</commit_message>
<xml_diff>
--- a/paper/tree_hyperlista_slides.pptx
+++ b/paper/tree_hyperlista_slides.pptx
@@ -19,6 +19,11 @@
     <p:sldId id="267" r:id="rId18"/>
     <p:sldId id="268" r:id="rId19"/>
     <p:sldId id="269" r:id="rId20"/>
+    <p:sldId id="270" r:id="rId21"/>
+    <p:sldId id="271" r:id="rId22"/>
+    <p:sldId id="272" r:id="rId23"/>
+    <p:sldId id="273" r:id="rId24"/>
+    <p:sldId id="274" r:id="rId25"/>
   </p:sldIdLst>
   <p:sldSz cx="12191695" cy="6858000" type="screen4x3"/>
   <p:notesSz cx="6858000" cy="9144000"/>
@@ -3179,7 +3184,7 @@
                 <a:solidFill>
                   <a:srgbClr val="1A478A"/>
                 </a:solidFill>
-                <a:latin typeface="Calibri Light"/>
+                <a:latin typeface="Calibri"/>
               </a:defRPr>
             </a:pPr>
             <a:r>
@@ -3536,7 +3541,7 @@
               </a:defRPr>
             </a:pPr>
             <a:r>
-              <a:t>  • 31.66 dB at CS 50%</a:t>
+              <a:t>  • 31.66 dB PSNR at CS 50%</a:t>
             </a:r>
           </a:p>
           <a:p>
@@ -3552,7 +3557,7 @@
               </a:defRPr>
             </a:pPr>
             <a:r>
-              <a:t>  • Beats HyperLISTA (3p) by 10+ dB at 50%</a:t>
+              <a:t>  • Beats HyperLISTA by 10+ dB</a:t>
             </a:r>
           </a:p>
           <a:p>
@@ -3632,7 +3637,7 @@
     <p:bg>
       <p:bgPr>
         <a:solidFill>
-          <a:srgbClr val="FFFFFF"/>
+          <a:srgbClr val="1A478A"/>
         </a:solidFill>
         <a:effectLst/>
       </p:bgPr>
@@ -3652,8 +3657,8 @@
         </p:nvSpPr>
         <p:spPr>
           <a:xfrm>
-            <a:off x="731520" y="365760"/>
-            <a:ext cx="10058400" cy="731520"/>
+            <a:off x="914400" y="2286000"/>
+            <a:ext cx="10058400" cy="1828800"/>
           </a:xfrm>
           <a:prstGeom prst="rect">
             <a:avLst/>
@@ -3666,260 +3671,16 @@
           </a:bodyPr>
           <a:lstStyle/>
           <a:p>
-            <a:pPr algn="l">
-              <a:defRPr sz="3600" b="1">
-                <a:solidFill>
-                  <a:srgbClr val="1A478A"/>
-                </a:solidFill>
-                <a:latin typeface="Calibri"/>
-              </a:defRPr>
-            </a:pPr>
-            <a:r>
-              <a:t>Backbone Ablation</a:t>
-            </a:r>
-          </a:p>
-        </p:txBody>
-      </p:sp>
-      <p:sp>
-        <p:nvSpPr>
-          <p:cNvPr id="3" name="Rectangle 2"/>
-          <p:cNvSpPr/>
-          <p:nvPr/>
-        </p:nvSpPr>
-        <p:spPr>
-          <a:xfrm>
-            <a:off x="731520" y="1005840"/>
-            <a:ext cx="2743200" cy="54864"/>
-          </a:xfrm>
-          <a:prstGeom prst="rect">
-            <a:avLst/>
-          </a:prstGeom>
-          <a:solidFill>
-            <a:srgbClr val="2E86C1"/>
-          </a:solidFill>
-          <a:ln>
-            <a:noFill/>
-          </a:ln>
-        </p:spPr>
-        <p:style>
-          <a:lnRef idx="1">
-            <a:schemeClr val="accent1"/>
-          </a:lnRef>
-          <a:fillRef idx="3">
-            <a:schemeClr val="accent1"/>
-          </a:fillRef>
-          <a:effectRef idx="2">
-            <a:schemeClr val="accent1"/>
-          </a:effectRef>
-          <a:fontRef idx="minor">
-            <a:schemeClr val="lt1"/>
-          </a:fontRef>
-        </p:style>
-        <p:txBody>
-          <a:bodyPr rtlCol="0" anchor="ctr"/>
-          <a:lstStyle/>
-          <a:p>
-            <a:pPr algn="ctr"/>
-          </a:p>
-        </p:txBody>
-      </p:sp>
-      <p:pic>
-        <p:nvPicPr>
-          <p:cNvPr id="4" name="Picture 3" descr="tree_fig_backbone.png"/>
-          <p:cNvPicPr>
-            <a:picLocks noChangeAspect="1"/>
-          </p:cNvPicPr>
-          <p:nvPr/>
-        </p:nvPicPr>
-        <p:blipFill>
-          <a:blip r:embed="rId2"/>
-          <a:stretch>
-            <a:fillRect/>
-          </a:stretch>
-        </p:blipFill>
-        <p:spPr>
-          <a:xfrm>
-            <a:off x="274320" y="1280160"/>
-            <a:ext cx="5943600" cy="3962400"/>
-          </a:xfrm>
-          <a:prstGeom prst="rect">
-            <a:avLst/>
-          </a:prstGeom>
-        </p:spPr>
-      </p:pic>
-      <p:sp>
-        <p:nvSpPr>
-          <p:cNvPr id="5" name="TextBox 4"/>
-          <p:cNvSpPr txBox="1"/>
-          <p:nvPr/>
-        </p:nvSpPr>
-        <p:spPr>
-          <a:xfrm>
-            <a:off x="6675120" y="1463040"/>
-            <a:ext cx="5029200" cy="5029200"/>
-          </a:xfrm>
-          <a:prstGeom prst="rect">
-            <a:avLst/>
-          </a:prstGeom>
-          <a:noFill/>
-        </p:spPr>
-        <p:txBody>
-          <a:bodyPr wrap="square">
-            <a:spAutoFit/>
-          </a:bodyPr>
-          <a:lstStyle/>
-          <a:p>
-            <a:pPr>
-              <a:spcAft>
-                <a:spcPts val="600"/>
-              </a:spcAft>
-              <a:defRPr sz="1900">
-                <a:solidFill>
-                  <a:srgbClr val="222222"/>
-                </a:solidFill>
-                <a:latin typeface="Calibri"/>
-              </a:defRPr>
-            </a:pPr>
-            <a:r>
-              <a:t>Compared 6 backbone variants:</a:t>
-            </a:r>
-          </a:p>
-          <a:p>
-            <a:pPr>
-              <a:spcAft>
-                <a:spcPts val="600"/>
-              </a:spcAft>
-              <a:defRPr sz="1900">
-                <a:solidFill>
-                  <a:srgbClr val="222222"/>
-                </a:solidFill>
-                <a:latin typeface="Calibri"/>
-              </a:defRPr>
-            </a:pPr>
-          </a:p>
-          <a:p>
-            <a:pPr>
-              <a:spcAft>
-                <a:spcPts val="600"/>
-              </a:spcAft>
-              <a:defRPr sz="1900">
-                <a:solidFill>
-                  <a:srgbClr val="222222"/>
-                </a:solidFill>
-                <a:latin typeface="Calibri"/>
-              </a:defRPr>
-            </a:pPr>
-            <a:r>
-              <a:t>Tree-ALISTA (32p):       −15.00 dB</a:t>
-            </a:r>
-          </a:p>
-          <a:p>
-            <a:pPr>
-              <a:spcAft>
-                <a:spcPts val="600"/>
-              </a:spcAft>
-              <a:defRPr sz="1900">
-                <a:solidFill>
-                  <a:srgbClr val="222222"/>
-                </a:solidFill>
-                <a:latin typeface="Calibri"/>
-              </a:defRPr>
-            </a:pPr>
-            <a:r>
-              <a:t>Tree-ALISTA-MM (32p):    −17.02 dB</a:t>
-            </a:r>
-          </a:p>
-          <a:p>
-            <a:pPr>
-              <a:spcAft>
-                <a:spcPts val="600"/>
-              </a:spcAft>
-              <a:defRPr sz="1900">
-                <a:solidFill>
-                  <a:srgbClr val="222222"/>
-                </a:solidFill>
-                <a:latin typeface="Calibri"/>
-              </a:defRPr>
-            </a:pPr>
-            <a:r>
-              <a:t>TH-Elem (3p, no tree):  −15.75 dB</a:t>
-            </a:r>
-          </a:p>
-          <a:p>
-            <a:pPr>
-              <a:spcAft>
-                <a:spcPts val="600"/>
-              </a:spcAft>
-              <a:defRPr sz="1900">
-                <a:solidFill>
-                  <a:srgbClr val="222222"/>
-                </a:solidFill>
-                <a:latin typeface="Calibri"/>
-              </a:defRPr>
-            </a:pPr>
-            <a:r>
-              <a:t>Tree-HyperLISTA (3p):   −28.66 dB</a:t>
-            </a:r>
-          </a:p>
-          <a:p>
-            <a:pPr>
-              <a:spcAft>
-                <a:spcPts val="600"/>
-              </a:spcAft>
-              <a:defRPr sz="1900">
-                <a:solidFill>
-                  <a:srgbClr val="222222"/>
-                </a:solidFill>
-                <a:latin typeface="Calibri"/>
-              </a:defRPr>
-            </a:pPr>
-          </a:p>
-          <a:p>
-            <a:pPr>
-              <a:spcAft>
-                <a:spcPts val="600"/>
-              </a:spcAft>
-              <a:defRPr sz="1900">
-                <a:solidFill>
-                  <a:srgbClr val="222222"/>
-                </a:solidFill>
-                <a:latin typeface="Calibri"/>
-              </a:defRPr>
-            </a:pPr>
-            <a:r>
-              <a:t>Key insight: tree-aware operator is</a:t>
-            </a:r>
-          </a:p>
-          <a:p>
-            <a:pPr>
-              <a:spcAft>
-                <a:spcPts val="600"/>
-              </a:spcAft>
-              <a:defRPr sz="1900">
-                <a:solidFill>
-                  <a:srgbClr val="222222"/>
-                </a:solidFill>
-                <a:latin typeface="Calibri"/>
-              </a:defRPr>
-            </a:pPr>
-            <a:r>
-              <a:t>the critical ingredient, not backbone</a:t>
-            </a:r>
-          </a:p>
-          <a:p>
-            <a:pPr>
-              <a:spcAft>
-                <a:spcPts val="600"/>
-              </a:spcAft>
-              <a:defRPr sz="1900">
-                <a:solidFill>
-                  <a:srgbClr val="222222"/>
-                </a:solidFill>
-                <a:latin typeface="Calibri"/>
-              </a:defRPr>
-            </a:pPr>
-            <a:r>
-              <a:t>complexity or parameter count</a:t>
+            <a:pPr algn="ctr">
+              <a:defRPr sz="4400" b="1">
+                <a:solidFill>
+                  <a:srgbClr val="FFFFFF"/>
+                </a:solidFill>
+                <a:latin typeface="Calibri"/>
+              </a:defRPr>
+            </a:pPr>
+            <a:r>
+              <a:t>Appendix: Extended Analysis</a:t>
             </a:r>
           </a:p>
         </p:txBody>
@@ -3981,7 +3742,827 @@
               </a:defRPr>
             </a:pPr>
             <a:r>
-              <a:t>Extended Robustness Analysis</a:t>
+              <a:t>Appendix B: Backbone Ablation</a:t>
+            </a:r>
+          </a:p>
+        </p:txBody>
+      </p:sp>
+      <p:sp>
+        <p:nvSpPr>
+          <p:cNvPr id="3" name="Rectangle 2"/>
+          <p:cNvSpPr/>
+          <p:nvPr/>
+        </p:nvSpPr>
+        <p:spPr>
+          <a:xfrm>
+            <a:off x="731520" y="1005840"/>
+            <a:ext cx="2743200" cy="54864"/>
+          </a:xfrm>
+          <a:prstGeom prst="rect">
+            <a:avLst/>
+          </a:prstGeom>
+          <a:solidFill>
+            <a:srgbClr val="2E86C1"/>
+          </a:solidFill>
+          <a:ln>
+            <a:noFill/>
+          </a:ln>
+        </p:spPr>
+        <p:style>
+          <a:lnRef idx="1">
+            <a:schemeClr val="accent1"/>
+          </a:lnRef>
+          <a:fillRef idx="3">
+            <a:schemeClr val="accent1"/>
+          </a:fillRef>
+          <a:effectRef idx="2">
+            <a:schemeClr val="accent1"/>
+          </a:effectRef>
+          <a:fontRef idx="minor">
+            <a:schemeClr val="lt1"/>
+          </a:fontRef>
+        </p:style>
+        <p:txBody>
+          <a:bodyPr rtlCol="0" anchor="ctr"/>
+          <a:lstStyle/>
+          <a:p>
+            <a:pPr algn="ctr"/>
+          </a:p>
+        </p:txBody>
+      </p:sp>
+      <p:pic>
+        <p:nvPicPr>
+          <p:cNvPr id="4" name="Picture 3" descr="tree_fig_backbone.png"/>
+          <p:cNvPicPr>
+            <a:picLocks noChangeAspect="1"/>
+          </p:cNvPicPr>
+          <p:nvPr/>
+        </p:nvPicPr>
+        <p:blipFill>
+          <a:blip r:embed="rId2"/>
+          <a:stretch>
+            <a:fillRect/>
+          </a:stretch>
+        </p:blipFill>
+        <p:spPr>
+          <a:xfrm>
+            <a:off x="274320" y="1280160"/>
+            <a:ext cx="5943600" cy="3962400"/>
+          </a:xfrm>
+          <a:prstGeom prst="rect">
+            <a:avLst/>
+          </a:prstGeom>
+        </p:spPr>
+      </p:pic>
+      <p:sp>
+        <p:nvSpPr>
+          <p:cNvPr id="5" name="TextBox 4"/>
+          <p:cNvSpPr txBox="1"/>
+          <p:nvPr/>
+        </p:nvSpPr>
+        <p:spPr>
+          <a:xfrm>
+            <a:off x="6675120" y="1463040"/>
+            <a:ext cx="5029200" cy="5029200"/>
+          </a:xfrm>
+          <a:prstGeom prst="rect">
+            <a:avLst/>
+          </a:prstGeom>
+          <a:noFill/>
+        </p:spPr>
+        <p:txBody>
+          <a:bodyPr wrap="square">
+            <a:spAutoFit/>
+          </a:bodyPr>
+          <a:lstStyle/>
+          <a:p>
+            <a:pPr>
+              <a:spcAft>
+                <a:spcPts val="600"/>
+              </a:spcAft>
+              <a:defRPr sz="1800">
+                <a:solidFill>
+                  <a:srgbClr val="222222"/>
+                </a:solidFill>
+                <a:latin typeface="Calibri"/>
+              </a:defRPr>
+            </a:pPr>
+            <a:r>
+              <a:t>6 backbone variants compared:</a:t>
+            </a:r>
+          </a:p>
+          <a:p>
+            <a:pPr>
+              <a:spcAft>
+                <a:spcPts val="600"/>
+              </a:spcAft>
+              <a:defRPr sz="1800">
+                <a:solidFill>
+                  <a:srgbClr val="222222"/>
+                </a:solidFill>
+                <a:latin typeface="Calibri"/>
+              </a:defRPr>
+            </a:pPr>
+          </a:p>
+          <a:p>
+            <a:pPr>
+              <a:spcAft>
+                <a:spcPts val="600"/>
+              </a:spcAft>
+              <a:defRPr sz="1800">
+                <a:solidFill>
+                  <a:srgbClr val="222222"/>
+                </a:solidFill>
+                <a:latin typeface="Calibri"/>
+              </a:defRPr>
+            </a:pPr>
+            <a:r>
+              <a:t>Tree-ALISTA (32p):       −15.00 dB</a:t>
+            </a:r>
+          </a:p>
+          <a:p>
+            <a:pPr>
+              <a:spcAft>
+                <a:spcPts val="600"/>
+              </a:spcAft>
+              <a:defRPr sz="1800">
+                <a:solidFill>
+                  <a:srgbClr val="222222"/>
+                </a:solidFill>
+                <a:latin typeface="Calibri"/>
+              </a:defRPr>
+            </a:pPr>
+            <a:r>
+              <a:t>Tree-ALISTA-MM (32p):    −17.02 dB</a:t>
+            </a:r>
+          </a:p>
+          <a:p>
+            <a:pPr>
+              <a:spcAft>
+                <a:spcPts val="600"/>
+              </a:spcAft>
+              <a:defRPr sz="1800">
+                <a:solidFill>
+                  <a:srgbClr val="222222"/>
+                </a:solidFill>
+                <a:latin typeface="Calibri"/>
+              </a:defRPr>
+            </a:pPr>
+            <a:r>
+              <a:t>ALISTA-MM-Sym (32p):     +38.80 (diverges!)</a:t>
+            </a:r>
+          </a:p>
+          <a:p>
+            <a:pPr>
+              <a:spcAft>
+                <a:spcPts val="600"/>
+              </a:spcAft>
+              <a:defRPr sz="1800">
+                <a:solidFill>
+                  <a:srgbClr val="222222"/>
+                </a:solidFill>
+                <a:latin typeface="Calibri"/>
+              </a:defRPr>
+            </a:pPr>
+            <a:r>
+              <a:t>TH-Elem (3p, no tree):   −15.75 dB</a:t>
+            </a:r>
+          </a:p>
+          <a:p>
+            <a:pPr>
+              <a:spcAft>
+                <a:spcPts val="600"/>
+              </a:spcAft>
+              <a:defRPr sz="1800">
+                <a:solidFill>
+                  <a:srgbClr val="222222"/>
+                </a:solidFill>
+                <a:latin typeface="Calibri"/>
+              </a:defRPr>
+            </a:pPr>
+            <a:r>
+              <a:t>Tree-HyperLISTA (3p):    −28.66 dB</a:t>
+            </a:r>
+          </a:p>
+          <a:p>
+            <a:pPr>
+              <a:spcAft>
+                <a:spcPts val="600"/>
+              </a:spcAft>
+              <a:defRPr sz="1800">
+                <a:solidFill>
+                  <a:srgbClr val="222222"/>
+                </a:solidFill>
+                <a:latin typeface="Calibri"/>
+              </a:defRPr>
+            </a:pPr>
+          </a:p>
+          <a:p>
+            <a:pPr>
+              <a:spcAft>
+                <a:spcPts val="600"/>
+              </a:spcAft>
+              <a:defRPr sz="1800">
+                <a:solidFill>
+                  <a:srgbClr val="222222"/>
+                </a:solidFill>
+                <a:latin typeface="Calibri"/>
+              </a:defRPr>
+            </a:pPr>
+            <a:r>
+              <a:t>Key: tree-aware operator is the</a:t>
+            </a:r>
+          </a:p>
+          <a:p>
+            <a:pPr>
+              <a:spcAft>
+                <a:spcPts val="600"/>
+              </a:spcAft>
+              <a:defRPr sz="1800">
+                <a:solidFill>
+                  <a:srgbClr val="222222"/>
+                </a:solidFill>
+                <a:latin typeface="Calibri"/>
+              </a:defRPr>
+            </a:pPr>
+            <a:r>
+              <a:t>critical ingredient, not backbone</a:t>
+            </a:r>
+          </a:p>
+          <a:p>
+            <a:pPr>
+              <a:spcAft>
+                <a:spcPts val="600"/>
+              </a:spcAft>
+              <a:defRPr sz="1800">
+                <a:solidFill>
+                  <a:srgbClr val="222222"/>
+                </a:solidFill>
+                <a:latin typeface="Calibri"/>
+              </a:defRPr>
+            </a:pPr>
+            <a:r>
+              <a:t>complexity or parameter count</a:t>
+            </a:r>
+          </a:p>
+        </p:txBody>
+      </p:sp>
+    </p:spTree>
+  </p:cSld>
+  <p:clrMapOvr>
+    <a:masterClrMapping/>
+  </p:clrMapOvr>
+</p:sld>
+</file>
+
+<file path=ppt/slides/slide13.xml><?xml version="1.0" encoding="utf-8"?>
+<p:sld xmlns:a="http://schemas.openxmlformats.org/drawingml/2006/main" xmlns:p="http://schemas.openxmlformats.org/presentationml/2006/main" xmlns:r="http://schemas.openxmlformats.org/officeDocument/2006/relationships">
+  <p:cSld>
+    <p:bg>
+      <p:bgPr>
+        <a:solidFill>
+          <a:srgbClr val="FFFFFF"/>
+        </a:solidFill>
+        <a:effectLst/>
+      </p:bgPr>
+    </p:bg>
+    <p:spTree>
+      <p:nvGrpSpPr>
+        <p:cNvPr id="1" name=""/>
+        <p:cNvGrpSpPr/>
+        <p:nvPr/>
+      </p:nvGrpSpPr>
+      <p:grpSpPr/>
+      <p:sp>
+        <p:nvSpPr>
+          <p:cNvPr id="2" name="TextBox 1"/>
+          <p:cNvSpPr txBox="1"/>
+          <p:nvPr/>
+        </p:nvSpPr>
+        <p:spPr>
+          <a:xfrm>
+            <a:off x="731520" y="365760"/>
+            <a:ext cx="10058400" cy="731520"/>
+          </a:xfrm>
+          <a:prstGeom prst="rect">
+            <a:avLst/>
+          </a:prstGeom>
+          <a:noFill/>
+        </p:spPr>
+        <p:txBody>
+          <a:bodyPr wrap="square">
+            <a:spAutoFit/>
+          </a:bodyPr>
+          <a:lstStyle/>
+          <a:p>
+            <a:pPr algn="l">
+              <a:defRPr sz="3600" b="1">
+                <a:solidFill>
+                  <a:srgbClr val="1A478A"/>
+                </a:solidFill>
+                <a:latin typeface="Calibri"/>
+              </a:defRPr>
+            </a:pPr>
+            <a:r>
+              <a:t>Appendix C: Extended Mechanism Ablation</a:t>
+            </a:r>
+          </a:p>
+        </p:txBody>
+      </p:sp>
+      <p:sp>
+        <p:nvSpPr>
+          <p:cNvPr id="3" name="Rectangle 2"/>
+          <p:cNvSpPr/>
+          <p:nvPr/>
+        </p:nvSpPr>
+        <p:spPr>
+          <a:xfrm>
+            <a:off x="731520" y="1005840"/>
+            <a:ext cx="2743200" cy="54864"/>
+          </a:xfrm>
+          <a:prstGeom prst="rect">
+            <a:avLst/>
+          </a:prstGeom>
+          <a:solidFill>
+            <a:srgbClr val="2E86C1"/>
+          </a:solidFill>
+          <a:ln>
+            <a:noFill/>
+          </a:ln>
+        </p:spPr>
+        <p:style>
+          <a:lnRef idx="1">
+            <a:schemeClr val="accent1"/>
+          </a:lnRef>
+          <a:fillRef idx="3">
+            <a:schemeClr val="accent1"/>
+          </a:fillRef>
+          <a:effectRef idx="2">
+            <a:schemeClr val="accent1"/>
+          </a:effectRef>
+          <a:fontRef idx="minor">
+            <a:schemeClr val="lt1"/>
+          </a:fontRef>
+        </p:style>
+        <p:txBody>
+          <a:bodyPr rtlCol="0" anchor="ctr"/>
+          <a:lstStyle/>
+          <a:p>
+            <a:pPr algn="ctr"/>
+          </a:p>
+        </p:txBody>
+      </p:sp>
+      <p:pic>
+        <p:nvPicPr>
+          <p:cNvPr id="4" name="Picture 3" descr="tree_fig_mechanisms_ext.png"/>
+          <p:cNvPicPr>
+            <a:picLocks noChangeAspect="1"/>
+          </p:cNvPicPr>
+          <p:nvPr/>
+        </p:nvPicPr>
+        <p:blipFill>
+          <a:blip r:embed="rId2"/>
+          <a:stretch>
+            <a:fillRect/>
+          </a:stretch>
+        </p:blipFill>
+        <p:spPr>
+          <a:xfrm>
+            <a:off x="274320" y="1280160"/>
+            <a:ext cx="5486400" cy="3376246"/>
+          </a:xfrm>
+          <a:prstGeom prst="rect">
+            <a:avLst/>
+          </a:prstGeom>
+        </p:spPr>
+      </p:pic>
+      <p:sp>
+        <p:nvSpPr>
+          <p:cNvPr id="5" name="TextBox 4"/>
+          <p:cNvSpPr txBox="1"/>
+          <p:nvPr/>
+        </p:nvSpPr>
+        <p:spPr>
+          <a:xfrm>
+            <a:off x="6400800" y="1463040"/>
+            <a:ext cx="5029200" cy="4572000"/>
+          </a:xfrm>
+          <a:prstGeom prst="rect">
+            <a:avLst/>
+          </a:prstGeom>
+          <a:noFill/>
+        </p:spPr>
+        <p:txBody>
+          <a:bodyPr wrap="square">
+            <a:spAutoFit/>
+          </a:bodyPr>
+          <a:lstStyle/>
+          <a:p>
+            <a:pPr>
+              <a:spcAft>
+                <a:spcPts val="600"/>
+              </a:spcAft>
+              <a:defRPr sz="1800">
+                <a:solidFill>
+                  <a:srgbClr val="222222"/>
+                </a:solidFill>
+                <a:latin typeface="Calibri"/>
+              </a:defRPr>
+            </a:pPr>
+            <a:r>
+              <a:t>Differentiable relaxations tested:</a:t>
+            </a:r>
+          </a:p>
+          <a:p>
+            <a:pPr>
+              <a:spcAft>
+                <a:spcPts val="600"/>
+              </a:spcAft>
+              <a:defRPr sz="1800">
+                <a:solidFill>
+                  <a:srgbClr val="222222"/>
+                </a:solidFill>
+                <a:latin typeface="Calibri"/>
+              </a:defRPr>
+            </a:pPr>
+          </a:p>
+          <a:p>
+            <a:pPr>
+              <a:spcAft>
+                <a:spcPts val="600"/>
+              </a:spcAft>
+              <a:defRPr sz="1800">
+                <a:solidFill>
+                  <a:srgbClr val="222222"/>
+                </a:solidFill>
+                <a:latin typeface="Calibri"/>
+              </a:defRPr>
+            </a:pPr>
+            <a:r>
+              <a:t>Tree Hard (M1):        −3.62 dB</a:t>
+            </a:r>
+          </a:p>
+          <a:p>
+            <a:pPr>
+              <a:spcAft>
+                <a:spcPts val="600"/>
+              </a:spcAft>
+              <a:defRPr sz="1800">
+                <a:solidFill>
+                  <a:srgbClr val="222222"/>
+                </a:solidFill>
+                <a:latin typeface="Calibri"/>
+              </a:defRPr>
+            </a:pPr>
+            <a:r>
+              <a:t>Diff. Ancestor:        −3.12 dB</a:t>
+            </a:r>
+          </a:p>
+          <a:p>
+            <a:pPr>
+              <a:spcAft>
+                <a:spcPts val="600"/>
+              </a:spcAft>
+              <a:defRPr sz="1800">
+                <a:solidFill>
+                  <a:srgbClr val="222222"/>
+                </a:solidFill>
+                <a:latin typeface="Calibri"/>
+              </a:defRPr>
+            </a:pPr>
+            <a:r>
+              <a:t>Gumbel Top-K:          −2.73 dB</a:t>
+            </a:r>
+          </a:p>
+          <a:p>
+            <a:pPr>
+              <a:spcAft>
+                <a:spcPts val="600"/>
+              </a:spcAft>
+              <a:defRPr sz="1800">
+                <a:solidFill>
+                  <a:srgbClr val="222222"/>
+                </a:solidFill>
+                <a:latin typeface="Calibri"/>
+              </a:defRPr>
+            </a:pPr>
+            <a:r>
+              <a:t>Threshold (M2):        −2.73 dB</a:t>
+            </a:r>
+          </a:p>
+          <a:p>
+            <a:pPr>
+              <a:spcAft>
+                <a:spcPts val="600"/>
+              </a:spcAft>
+              <a:defRPr sz="1800">
+                <a:solidFill>
+                  <a:srgbClr val="222222"/>
+                </a:solidFill>
+                <a:latin typeface="Calibri"/>
+              </a:defRPr>
+            </a:pPr>
+            <a:r>
+              <a:t>Hybrid (M3):           −2.73 dB</a:t>
+            </a:r>
+          </a:p>
+          <a:p>
+            <a:pPr>
+              <a:spcAft>
+                <a:spcPts val="600"/>
+              </a:spcAft>
+              <a:defRPr sz="1800">
+                <a:solidFill>
+                  <a:srgbClr val="222222"/>
+                </a:solidFill>
+                <a:latin typeface="Calibri"/>
+              </a:defRPr>
+            </a:pPr>
+          </a:p>
+          <a:p>
+            <a:pPr>
+              <a:spcAft>
+                <a:spcPts val="600"/>
+              </a:spcAft>
+              <a:defRPr sz="1800">
+                <a:solidFill>
+                  <a:srgbClr val="222222"/>
+                </a:solidFill>
+                <a:latin typeface="Calibri"/>
+              </a:defRPr>
+            </a:pPr>
+            <a:r>
+              <a:t>Non-differentiable hard projection</a:t>
+            </a:r>
+          </a:p>
+          <a:p>
+            <a:pPr>
+              <a:spcAft>
+                <a:spcPts val="600"/>
+              </a:spcAft>
+              <a:defRPr sz="1800">
+                <a:solidFill>
+                  <a:srgbClr val="222222"/>
+                </a:solidFill>
+                <a:latin typeface="Calibri"/>
+              </a:defRPr>
+            </a:pPr>
+            <a:r>
+              <a:t>outperforms smooth relaxations</a:t>
+            </a:r>
+          </a:p>
+        </p:txBody>
+      </p:sp>
+    </p:spTree>
+  </p:cSld>
+  <p:clrMapOvr>
+    <a:masterClrMapping/>
+  </p:clrMapOvr>
+</p:sld>
+</file>
+
+<file path=ppt/slides/slide14.xml><?xml version="1.0" encoding="utf-8"?>
+<p:sld xmlns:a="http://schemas.openxmlformats.org/drawingml/2006/main" xmlns:p="http://schemas.openxmlformats.org/presentationml/2006/main" xmlns:r="http://schemas.openxmlformats.org/officeDocument/2006/relationships">
+  <p:cSld>
+    <p:bg>
+      <p:bgPr>
+        <a:solidFill>
+          <a:srgbClr val="FFFFFF"/>
+        </a:solidFill>
+        <a:effectLst/>
+      </p:bgPr>
+    </p:bg>
+    <p:spTree>
+      <p:nvGrpSpPr>
+        <p:cNvPr id="1" name=""/>
+        <p:cNvGrpSpPr/>
+        <p:nvPr/>
+      </p:nvGrpSpPr>
+      <p:grpSpPr/>
+      <p:sp>
+        <p:nvSpPr>
+          <p:cNvPr id="2" name="TextBox 1"/>
+          <p:cNvSpPr txBox="1"/>
+          <p:nvPr/>
+        </p:nvSpPr>
+        <p:spPr>
+          <a:xfrm>
+            <a:off x="731520" y="365760"/>
+            <a:ext cx="10058400" cy="731520"/>
+          </a:xfrm>
+          <a:prstGeom prst="rect">
+            <a:avLst/>
+          </a:prstGeom>
+          <a:noFill/>
+        </p:spPr>
+        <p:txBody>
+          <a:bodyPr wrap="square">
+            <a:spAutoFit/>
+          </a:bodyPr>
+          <a:lstStyle/>
+          <a:p>
+            <a:pPr algn="l">
+              <a:defRPr sz="3600" b="1">
+                <a:solidFill>
+                  <a:srgbClr val="1A478A"/>
+                </a:solidFill>
+                <a:latin typeface="Calibri"/>
+              </a:defRPr>
+            </a:pPr>
+            <a:r>
+              <a:t>Appendix D-E: Rho Sensitivity &amp; Sparsity Mismatch</a:t>
+            </a:r>
+          </a:p>
+        </p:txBody>
+      </p:sp>
+      <p:sp>
+        <p:nvSpPr>
+          <p:cNvPr id="3" name="Rectangle 2"/>
+          <p:cNvSpPr/>
+          <p:nvPr/>
+        </p:nvSpPr>
+        <p:spPr>
+          <a:xfrm>
+            <a:off x="731520" y="1005840"/>
+            <a:ext cx="2743200" cy="54864"/>
+          </a:xfrm>
+          <a:prstGeom prst="rect">
+            <a:avLst/>
+          </a:prstGeom>
+          <a:solidFill>
+            <a:srgbClr val="2E86C1"/>
+          </a:solidFill>
+          <a:ln>
+            <a:noFill/>
+          </a:ln>
+        </p:spPr>
+        <p:style>
+          <a:lnRef idx="1">
+            <a:schemeClr val="accent1"/>
+          </a:lnRef>
+          <a:fillRef idx="3">
+            <a:schemeClr val="accent1"/>
+          </a:fillRef>
+          <a:effectRef idx="2">
+            <a:schemeClr val="accent1"/>
+          </a:effectRef>
+          <a:fontRef idx="minor">
+            <a:schemeClr val="lt1"/>
+          </a:fontRef>
+        </p:style>
+        <p:txBody>
+          <a:bodyPr rtlCol="0" anchor="ctr"/>
+          <a:lstStyle/>
+          <a:p>
+            <a:pPr algn="ctr"/>
+          </a:p>
+        </p:txBody>
+      </p:sp>
+      <p:pic>
+        <p:nvPicPr>
+          <p:cNvPr id="4" name="Picture 3" descr="tree_fig_rho_dense.png"/>
+          <p:cNvPicPr>
+            <a:picLocks noChangeAspect="1"/>
+          </p:cNvPicPr>
+          <p:nvPr/>
+        </p:nvPicPr>
+        <p:blipFill>
+          <a:blip r:embed="rId2"/>
+          <a:stretch>
+            <a:fillRect/>
+          </a:stretch>
+        </p:blipFill>
+        <p:spPr>
+          <a:xfrm>
+            <a:off x="274320" y="1280160"/>
+            <a:ext cx="5029200" cy="3352800"/>
+          </a:xfrm>
+          <a:prstGeom prst="rect">
+            <a:avLst/>
+          </a:prstGeom>
+        </p:spPr>
+      </p:pic>
+      <p:pic>
+        <p:nvPicPr>
+          <p:cNvPr id="5" name="Picture 4" descr="tree_fig_sparsity.png"/>
+          <p:cNvPicPr>
+            <a:picLocks noChangeAspect="1"/>
+          </p:cNvPicPr>
+          <p:nvPr/>
+        </p:nvPicPr>
+        <p:blipFill>
+          <a:blip r:embed="rId3"/>
+          <a:stretch>
+            <a:fillRect/>
+          </a:stretch>
+        </p:blipFill>
+        <p:spPr>
+          <a:xfrm>
+            <a:off x="5943600" y="1280160"/>
+            <a:ext cx="5486400" cy="3716594"/>
+          </a:xfrm>
+          <a:prstGeom prst="rect">
+            <a:avLst/>
+          </a:prstGeom>
+        </p:spPr>
+      </p:pic>
+      <p:sp>
+        <p:nvSpPr>
+          <p:cNvPr id="6" name="TextBox 5"/>
+          <p:cNvSpPr txBox="1"/>
+          <p:nvPr/>
+        </p:nvSpPr>
+        <p:spPr>
+          <a:xfrm>
+            <a:off x="457200" y="5303520"/>
+            <a:ext cx="10972800" cy="1097280"/>
+          </a:xfrm>
+          <a:prstGeom prst="rect">
+            <a:avLst/>
+          </a:prstGeom>
+          <a:noFill/>
+        </p:spPr>
+        <p:txBody>
+          <a:bodyPr wrap="square">
+            <a:spAutoFit/>
+          </a:bodyPr>
+          <a:lstStyle/>
+          <a:p>
+            <a:pPr>
+              <a:spcAft>
+                <a:spcPts val="600"/>
+              </a:spcAft>
+              <a:defRPr sz="1600">
+                <a:solidFill>
+                  <a:srgbClr val="666666"/>
+                </a:solidFill>
+                <a:latin typeface="Calibri"/>
+              </a:defRPr>
+            </a:pPr>
+            <a:r>
+              <a:t>Left: ρ=0.1 and ρ=0.5 give same result — robust to decay choice  |  Right: graceful at sparser; all methods degrade when denser</a:t>
+            </a:r>
+          </a:p>
+        </p:txBody>
+      </p:sp>
+    </p:spTree>
+  </p:cSld>
+  <p:clrMapOvr>
+    <a:masterClrMapping/>
+  </p:clrMapOvr>
+</p:sld>
+</file>
+
+<file path=ppt/slides/slide15.xml><?xml version="1.0" encoding="utf-8"?>
+<p:sld xmlns:a="http://schemas.openxmlformats.org/drawingml/2006/main" xmlns:p="http://schemas.openxmlformats.org/presentationml/2006/main" xmlns:r="http://schemas.openxmlformats.org/officeDocument/2006/relationships">
+  <p:cSld>
+    <p:bg>
+      <p:bgPr>
+        <a:solidFill>
+          <a:srgbClr val="FFFFFF"/>
+        </a:solidFill>
+        <a:effectLst/>
+      </p:bgPr>
+    </p:bg>
+    <p:spTree>
+      <p:nvGrpSpPr>
+        <p:cNvPr id="1" name=""/>
+        <p:cNvGrpSpPr/>
+        <p:nvPr/>
+      </p:nvGrpSpPr>
+      <p:grpSpPr/>
+      <p:sp>
+        <p:nvSpPr>
+          <p:cNvPr id="2" name="TextBox 1"/>
+          <p:cNvSpPr txBox="1"/>
+          <p:nvPr/>
+        </p:nvSpPr>
+        <p:spPr>
+          <a:xfrm>
+            <a:off x="731520" y="365760"/>
+            <a:ext cx="10058400" cy="731520"/>
+          </a:xfrm>
+          <a:prstGeom prst="rect">
+            <a:avLst/>
+          </a:prstGeom>
+          <a:noFill/>
+        </p:spPr>
+        <p:txBody>
+          <a:bodyPr wrap="square">
+            <a:spAutoFit/>
+          </a:bodyPr>
+          <a:lstStyle/>
+          <a:p>
+            <a:pPr algn="l">
+              <a:defRPr sz="3600" b="1">
+                <a:solidFill>
+                  <a:srgbClr val="1A478A"/>
+                </a:solidFill>
+                <a:latin typeface="Calibri"/>
+              </a:defRPr>
+            </a:pPr>
+            <a:r>
+              <a:t>Appendix F: Extended Mismatch Robustness</a:t>
             </a:r>
           </a:p>
         </p:txBody>
@@ -4085,7 +4666,7 @@
         </p:nvSpPr>
         <p:spPr>
           <a:xfrm>
-            <a:off x="457200" y="5486400"/>
+            <a:off x="457200" y="5120640"/>
             <a:ext cx="10972800" cy="914400"/>
           </a:xfrm>
           <a:prstGeom prst="rect">
@@ -4100,7 +4681,7 @@
           <a:lstStyle/>
           <a:p>
             <a:pPr algn="ctr">
-              <a:defRPr sz="1700" b="0">
+              <a:defRPr sz="1600" b="0">
                 <a:solidFill>
                   <a:srgbClr val="666666"/>
                 </a:solidFill>
@@ -4108,7 +4689,43 @@
               </a:defRPr>
             </a:pPr>
             <a:r>
-              <a:t>Robust to magnitude scaling (−28.7→−28.1 dB at 3×)  |  Graceful degradation as tree consistency decreases</a:t>
+              <a:t>Magnitude scaling: TH robust (−28.7→−28.1 dB at 3×) while HyperLISTA diverges (+85 dB)</a:t>
+            </a:r>
+          </a:p>
+        </p:txBody>
+      </p:sp>
+      <p:sp>
+        <p:nvSpPr>
+          <p:cNvPr id="7" name="TextBox 6"/>
+          <p:cNvSpPr txBox="1"/>
+          <p:nvPr/>
+        </p:nvSpPr>
+        <p:spPr>
+          <a:xfrm>
+            <a:off x="457200" y="5577840"/>
+            <a:ext cx="10972800" cy="914400"/>
+          </a:xfrm>
+          <a:prstGeom prst="rect">
+            <a:avLst/>
+          </a:prstGeom>
+          <a:noFill/>
+        </p:spPr>
+        <p:txBody>
+          <a:bodyPr wrap="square">
+            <a:spAutoFit/>
+          </a:bodyPr>
+          <a:lstStyle/>
+          <a:p>
+            <a:pPr algn="ctr">
+              <a:defRPr sz="1600" b="0">
+                <a:solidFill>
+                  <a:srgbClr val="666666"/>
+                </a:solidFill>
+                <a:latin typeface="Calibri"/>
+              </a:defRPr>
+            </a:pPr>
+            <a:r>
+              <a:t>Tree consistency: TH degrades from −28.8 to −7.2 dB as tree structure breaks — expected behavior</a:t>
             </a:r>
           </a:p>
         </p:txBody>
@@ -4121,7 +4738,502 @@
 </p:sld>
 </file>
 
-<file path=ppt/slides/slide13.xml><?xml version="1.0" encoding="utf-8"?>
+<file path=ppt/slides/slide16.xml><?xml version="1.0" encoding="utf-8"?>
+<p:sld xmlns:a="http://schemas.openxmlformats.org/drawingml/2006/main" xmlns:p="http://schemas.openxmlformats.org/presentationml/2006/main" xmlns:r="http://schemas.openxmlformats.org/officeDocument/2006/relationships">
+  <p:cSld>
+    <p:bg>
+      <p:bgPr>
+        <a:solidFill>
+          <a:srgbClr val="FFFFFF"/>
+        </a:solidFill>
+        <a:effectLst/>
+      </p:bgPr>
+    </p:bg>
+    <p:spTree>
+      <p:nvGrpSpPr>
+        <p:cNvPr id="1" name=""/>
+        <p:cNvGrpSpPr/>
+        <p:nvPr/>
+      </p:nvGrpSpPr>
+      <p:grpSpPr/>
+      <p:sp>
+        <p:nvSpPr>
+          <p:cNvPr id="2" name="TextBox 1"/>
+          <p:cNvSpPr txBox="1"/>
+          <p:nvPr/>
+        </p:nvSpPr>
+        <p:spPr>
+          <a:xfrm>
+            <a:off x="731520" y="365760"/>
+            <a:ext cx="10058400" cy="731520"/>
+          </a:xfrm>
+          <a:prstGeom prst="rect">
+            <a:avLst/>
+          </a:prstGeom>
+          <a:noFill/>
+        </p:spPr>
+        <p:txBody>
+          <a:bodyPr wrap="square">
+            <a:spAutoFit/>
+          </a:bodyPr>
+          <a:lstStyle/>
+          <a:p>
+            <a:pPr algn="l">
+              <a:defRPr sz="3600" b="1">
+                <a:solidFill>
+                  <a:srgbClr val="1A478A"/>
+                </a:solidFill>
+                <a:latin typeface="Calibri"/>
+              </a:defRPr>
+            </a:pPr>
+            <a:r>
+              <a:t>Appendix G-H: Low-SNR &amp; Superlinear Convergence</a:t>
+            </a:r>
+          </a:p>
+        </p:txBody>
+      </p:sp>
+      <p:sp>
+        <p:nvSpPr>
+          <p:cNvPr id="3" name="Rectangle 2"/>
+          <p:cNvSpPr/>
+          <p:nvPr/>
+        </p:nvSpPr>
+        <p:spPr>
+          <a:xfrm>
+            <a:off x="731520" y="1005840"/>
+            <a:ext cx="2743200" cy="54864"/>
+          </a:xfrm>
+          <a:prstGeom prst="rect">
+            <a:avLst/>
+          </a:prstGeom>
+          <a:solidFill>
+            <a:srgbClr val="2E86C1"/>
+          </a:solidFill>
+          <a:ln>
+            <a:noFill/>
+          </a:ln>
+        </p:spPr>
+        <p:style>
+          <a:lnRef idx="1">
+            <a:schemeClr val="accent1"/>
+          </a:lnRef>
+          <a:fillRef idx="3">
+            <a:schemeClr val="accent1"/>
+          </a:fillRef>
+          <a:effectRef idx="2">
+            <a:schemeClr val="accent1"/>
+          </a:effectRef>
+          <a:fontRef idx="minor">
+            <a:schemeClr val="lt1"/>
+          </a:fontRef>
+        </p:style>
+        <p:txBody>
+          <a:bodyPr rtlCol="0" anchor="ctr"/>
+          <a:lstStyle/>
+          <a:p>
+            <a:pPr algn="ctr"/>
+          </a:p>
+        </p:txBody>
+      </p:sp>
+      <p:pic>
+        <p:nvPicPr>
+          <p:cNvPr id="4" name="Picture 3" descr="tree_fig_lowsnr.png"/>
+          <p:cNvPicPr>
+            <a:picLocks noChangeAspect="1"/>
+          </p:cNvPicPr>
+          <p:nvPr/>
+        </p:nvPicPr>
+        <p:blipFill>
+          <a:blip r:embed="rId2"/>
+          <a:stretch>
+            <a:fillRect/>
+          </a:stretch>
+        </p:blipFill>
+        <p:spPr>
+          <a:xfrm>
+            <a:off x="274320" y="1280160"/>
+            <a:ext cx="5303520" cy="3535680"/>
+          </a:xfrm>
+          <a:prstGeom prst="rect">
+            <a:avLst/>
+          </a:prstGeom>
+        </p:spPr>
+      </p:pic>
+      <p:pic>
+        <p:nvPicPr>
+          <p:cNvPr id="5" name="Picture 4" descr="tree_fig_superlinear.png"/>
+          <p:cNvPicPr>
+            <a:picLocks noChangeAspect="1"/>
+          </p:cNvPicPr>
+          <p:nvPr/>
+        </p:nvPicPr>
+        <p:blipFill>
+          <a:blip r:embed="rId3"/>
+          <a:stretch>
+            <a:fillRect/>
+          </a:stretch>
+        </p:blipFill>
+        <p:spPr>
+          <a:xfrm>
+            <a:off x="6217920" y="1280160"/>
+            <a:ext cx="5303520" cy="3646170"/>
+          </a:xfrm>
+          <a:prstGeom prst="rect">
+            <a:avLst/>
+          </a:prstGeom>
+        </p:spPr>
+      </p:pic>
+      <p:sp>
+        <p:nvSpPr>
+          <p:cNvPr id="6" name="TextBox 5"/>
+          <p:cNvSpPr txBox="1"/>
+          <p:nvPr/>
+        </p:nvSpPr>
+        <p:spPr>
+          <a:xfrm>
+            <a:off x="457200" y="5303520"/>
+            <a:ext cx="10972800" cy="1097280"/>
+          </a:xfrm>
+          <a:prstGeom prst="rect">
+            <a:avLst/>
+          </a:prstGeom>
+          <a:noFill/>
+        </p:spPr>
+        <p:txBody>
+          <a:bodyPr wrap="square">
+            <a:spAutoFit/>
+          </a:bodyPr>
+          <a:lstStyle/>
+          <a:p>
+            <a:pPr>
+              <a:spcAft>
+                <a:spcPts val="600"/>
+              </a:spcAft>
+              <a:defRPr sz="1600">
+                <a:solidFill>
+                  <a:srgbClr val="666666"/>
+                </a:solidFill>
+                <a:latin typeface="Calibri"/>
+              </a:defRPr>
+            </a:pPr>
+            <a:r>
+              <a:t>Left: TH maintains advantage at all SNR levels (10/20/30 dB)  |  Right: per-instance tuning → −4.0 dB at only 6 layers (future work)</a:t>
+            </a:r>
+          </a:p>
+        </p:txBody>
+      </p:sp>
+    </p:spTree>
+  </p:cSld>
+  <p:clrMapOvr>
+    <a:masterClrMapping/>
+  </p:clrMapOvr>
+</p:sld>
+</file>
+
+<file path=ppt/slides/slide17.xml><?xml version="1.0" encoding="utf-8"?>
+<p:sld xmlns:a="http://schemas.openxmlformats.org/drawingml/2006/main" xmlns:p="http://schemas.openxmlformats.org/presentationml/2006/main" xmlns:r="http://schemas.openxmlformats.org/officeDocument/2006/relationships">
+  <p:cSld>
+    <p:bg>
+      <p:bgPr>
+        <a:solidFill>
+          <a:srgbClr val="FFFFFF"/>
+        </a:solidFill>
+        <a:effectLst/>
+      </p:bgPr>
+    </p:bg>
+    <p:spTree>
+      <p:nvGrpSpPr>
+        <p:cNvPr id="1" name=""/>
+        <p:cNvGrpSpPr/>
+        <p:nvPr/>
+      </p:nvGrpSpPr>
+      <p:grpSpPr/>
+      <p:sp>
+        <p:nvSpPr>
+          <p:cNvPr id="2" name="TextBox 1"/>
+          <p:cNvSpPr txBox="1"/>
+          <p:nvPr/>
+        </p:nvSpPr>
+        <p:spPr>
+          <a:xfrm>
+            <a:off x="731520" y="365760"/>
+            <a:ext cx="10058400" cy="731520"/>
+          </a:xfrm>
+          <a:prstGeom prst="rect">
+            <a:avLst/>
+          </a:prstGeom>
+          <a:noFill/>
+        </p:spPr>
+        <p:txBody>
+          <a:bodyPr wrap="square">
+            <a:spAutoFit/>
+          </a:bodyPr>
+          <a:lstStyle/>
+          <a:p>
+            <a:pPr algn="l">
+              <a:defRPr sz="3600" b="1">
+                <a:solidFill>
+                  <a:srgbClr val="1A478A"/>
+                </a:solidFill>
+                <a:latin typeface="Calibri"/>
+              </a:defRPr>
+            </a:pPr>
+            <a:r>
+              <a:t>Appendix I: Cross-Structure Experiments</a:t>
+            </a:r>
+          </a:p>
+        </p:txBody>
+      </p:sp>
+      <p:sp>
+        <p:nvSpPr>
+          <p:cNvPr id="3" name="Rectangle 2"/>
+          <p:cNvSpPr/>
+          <p:nvPr/>
+        </p:nvSpPr>
+        <p:spPr>
+          <a:xfrm>
+            <a:off x="731520" y="1005840"/>
+            <a:ext cx="2743200" cy="54864"/>
+          </a:xfrm>
+          <a:prstGeom prst="rect">
+            <a:avLst/>
+          </a:prstGeom>
+          <a:solidFill>
+            <a:srgbClr val="2E86C1"/>
+          </a:solidFill>
+          <a:ln>
+            <a:noFill/>
+          </a:ln>
+        </p:spPr>
+        <p:style>
+          <a:lnRef idx="1">
+            <a:schemeClr val="accent1"/>
+          </a:lnRef>
+          <a:fillRef idx="3">
+            <a:schemeClr val="accent1"/>
+          </a:fillRef>
+          <a:effectRef idx="2">
+            <a:schemeClr val="accent1"/>
+          </a:effectRef>
+          <a:fontRef idx="minor">
+            <a:schemeClr val="lt1"/>
+          </a:fontRef>
+        </p:style>
+        <p:txBody>
+          <a:bodyPr rtlCol="0" anchor="ctr"/>
+          <a:lstStyle/>
+          <a:p>
+            <a:pPr algn="ctr"/>
+          </a:p>
+        </p:txBody>
+      </p:sp>
+      <p:pic>
+        <p:nvPicPr>
+          <p:cNvPr id="4" name="Picture 3" descr="tree_fig_cross.png"/>
+          <p:cNvPicPr>
+            <a:picLocks noChangeAspect="1"/>
+          </p:cNvPicPr>
+          <p:nvPr/>
+        </p:nvPicPr>
+        <p:blipFill>
+          <a:blip r:embed="rId2"/>
+          <a:stretch>
+            <a:fillRect/>
+          </a:stretch>
+        </p:blipFill>
+        <p:spPr>
+          <a:xfrm>
+            <a:off x="914400" y="1280160"/>
+            <a:ext cx="5486400" cy="3840480"/>
+          </a:xfrm>
+          <a:prstGeom prst="rect">
+            <a:avLst/>
+          </a:prstGeom>
+        </p:spPr>
+      </p:pic>
+      <p:sp>
+        <p:nvSpPr>
+          <p:cNvPr id="5" name="TextBox 4"/>
+          <p:cNvSpPr txBox="1"/>
+          <p:nvPr/>
+        </p:nvSpPr>
+        <p:spPr>
+          <a:xfrm>
+            <a:off x="6858000" y="1463040"/>
+            <a:ext cx="4572000" cy="4572000"/>
+          </a:xfrm>
+          <a:prstGeom prst="rect">
+            <a:avLst/>
+          </a:prstGeom>
+          <a:noFill/>
+        </p:spPr>
+        <p:txBody>
+          <a:bodyPr wrap="square">
+            <a:spAutoFit/>
+          </a:bodyPr>
+          <a:lstStyle/>
+          <a:p>
+            <a:pPr>
+              <a:spcAft>
+                <a:spcPts val="600"/>
+              </a:spcAft>
+              <a:defRPr sz="1800">
+                <a:solidFill>
+                  <a:srgbClr val="222222"/>
+                </a:solidFill>
+                <a:latin typeface="Calibri"/>
+              </a:defRPr>
+            </a:pPr>
+            <a:r>
+              <a:t>Train on tree-sparse, test on elementwise:</a:t>
+            </a:r>
+          </a:p>
+          <a:p>
+            <a:pPr>
+              <a:spcAft>
+                <a:spcPts val="600"/>
+              </a:spcAft>
+              <a:defRPr sz="1800">
+                <a:solidFill>
+                  <a:srgbClr val="222222"/>
+                </a:solidFill>
+                <a:latin typeface="Calibri"/>
+              </a:defRPr>
+            </a:pPr>
+          </a:p>
+          <a:p>
+            <a:pPr>
+              <a:spcAft>
+                <a:spcPts val="600"/>
+              </a:spcAft>
+              <a:defRPr sz="1800">
+                <a:solidFill>
+                  <a:srgbClr val="222222"/>
+                </a:solidFill>
+                <a:latin typeface="Calibri"/>
+              </a:defRPr>
+            </a:pPr>
+            <a:r>
+              <a:t>TH-hybrid on non-tree data: −3.45 dB</a:t>
+            </a:r>
+          </a:p>
+          <a:p>
+            <a:pPr>
+              <a:spcAft>
+                <a:spcPts val="600"/>
+              </a:spcAft>
+              <a:defRPr sz="1800">
+                <a:solidFill>
+                  <a:srgbClr val="222222"/>
+                </a:solidFill>
+                <a:latin typeface="Calibri"/>
+              </a:defRPr>
+            </a:pPr>
+            <a:r>
+              <a:t>TH-hybrid on tree data:     −2.73 dB</a:t>
+            </a:r>
+          </a:p>
+          <a:p>
+            <a:pPr>
+              <a:spcAft>
+                <a:spcPts val="600"/>
+              </a:spcAft>
+              <a:defRPr sz="1800">
+                <a:solidFill>
+                  <a:srgbClr val="222222"/>
+                </a:solidFill>
+                <a:latin typeface="Calibri"/>
+              </a:defRPr>
+            </a:pPr>
+          </a:p>
+          <a:p>
+            <a:pPr>
+              <a:spcAft>
+                <a:spcPts val="600"/>
+              </a:spcAft>
+              <a:defRPr sz="1800">
+                <a:solidFill>
+                  <a:srgbClr val="222222"/>
+                </a:solidFill>
+                <a:latin typeface="Calibri"/>
+              </a:defRPr>
+            </a:pPr>
+            <a:r>
+              <a:t>Tree-aware method does NOT hurt</a:t>
+            </a:r>
+          </a:p>
+          <a:p>
+            <a:pPr>
+              <a:spcAft>
+                <a:spcPts val="600"/>
+              </a:spcAft>
+              <a:defRPr sz="1800">
+                <a:solidFill>
+                  <a:srgbClr val="222222"/>
+                </a:solidFill>
+                <a:latin typeface="Calibri"/>
+              </a:defRPr>
+            </a:pPr>
+            <a:r>
+              <a:t>performance on non-tree signals</a:t>
+            </a:r>
+          </a:p>
+          <a:p>
+            <a:pPr>
+              <a:spcAft>
+                <a:spcPts val="600"/>
+              </a:spcAft>
+              <a:defRPr sz="1800">
+                <a:solidFill>
+                  <a:srgbClr val="222222"/>
+                </a:solidFill>
+                <a:latin typeface="Calibri"/>
+              </a:defRPr>
+            </a:pPr>
+          </a:p>
+          <a:p>
+            <a:pPr>
+              <a:spcAft>
+                <a:spcPts val="600"/>
+              </a:spcAft>
+              <a:defRPr sz="1800">
+                <a:solidFill>
+                  <a:srgbClr val="222222"/>
+                </a:solidFill>
+                <a:latin typeface="Calibri"/>
+              </a:defRPr>
+            </a:pPr>
+            <a:r>
+              <a:t>→ Safe to use tree operator even</a:t>
+            </a:r>
+          </a:p>
+          <a:p>
+            <a:pPr>
+              <a:spcAft>
+                <a:spcPts val="600"/>
+              </a:spcAft>
+              <a:defRPr sz="1800">
+                <a:solidFill>
+                  <a:srgbClr val="222222"/>
+                </a:solidFill>
+                <a:latin typeface="Calibri"/>
+              </a:defRPr>
+            </a:pPr>
+            <a:r>
+              <a:t>   when structure is uncertain</a:t>
+            </a:r>
+          </a:p>
+        </p:txBody>
+      </p:sp>
+    </p:spTree>
+  </p:cSld>
+  <p:clrMapOvr>
+    <a:masterClrMapping/>
+  </p:clrMapOvr>
+</p:sld>
+</file>
+
+<file path=ppt/slides/slide18.xml><?xml version="1.0" encoding="utf-8"?>
 <p:sld xmlns:a="http://schemas.openxmlformats.org/drawingml/2006/main" xmlns:p="http://schemas.openxmlformats.org/presentationml/2006/main" xmlns:r="http://schemas.openxmlformats.org/officeDocument/2006/relationships">
   <p:cSld>
     <p:bg>
@@ -4183,7 +5295,7 @@
         </p:nvSpPr>
         <p:spPr>
           <a:xfrm>
-            <a:off x="1097280" y="1417320"/>
+            <a:off x="1097280" y="1234440"/>
             <a:ext cx="548640" cy="548640"/>
           </a:xfrm>
           <a:prstGeom prst="ellipse">
@@ -4235,7 +5347,7 @@
         </p:nvSpPr>
         <p:spPr>
           <a:xfrm>
-            <a:off x="2011680" y="1371600"/>
+            <a:off x="2011680" y="1188720"/>
             <a:ext cx="8229600" cy="457200"/>
           </a:xfrm>
           <a:prstGeom prst="rect">
@@ -4271,7 +5383,7 @@
         </p:nvSpPr>
         <p:spPr>
           <a:xfrm>
-            <a:off x="2011680" y="1828800"/>
+            <a:off x="2011680" y="1600200"/>
             <a:ext cx="8229600" cy="457200"/>
           </a:xfrm>
           <a:prstGeom prst="rect">
@@ -4286,7 +5398,7 @@
           <a:lstStyle/>
           <a:p>
             <a:pPr algn="l">
-              <a:defRPr sz="1800" b="0">
+              <a:defRPr sz="1700" b="0">
                 <a:solidFill>
                   <a:srgbClr val="666666"/>
                 </a:solidFill>
@@ -4294,7 +5406,7 @@
               </a:defRPr>
             </a:pPr>
             <a:r>
-              <a:t>3 params with tree-aware operator beats 1.56M params (LISTA) by 15.5 dB</a:t>
+              <a:t>3 params + tree operator beats 1.56M params (LISTA) by 15.5 dB</a:t>
             </a:r>
           </a:p>
         </p:txBody>
@@ -4307,7 +5419,7 @@
         </p:nvSpPr>
         <p:spPr>
           <a:xfrm>
-            <a:off x="1097280" y="2697479"/>
+            <a:off x="1097280" y="2286000"/>
             <a:ext cx="548640" cy="548640"/>
           </a:xfrm>
           <a:prstGeom prst="ellipse">
@@ -4359,7 +5471,7 @@
         </p:nvSpPr>
         <p:spPr>
           <a:xfrm>
-            <a:off x="2011680" y="2651760"/>
+            <a:off x="2011680" y="2240280"/>
             <a:ext cx="8229600" cy="457200"/>
           </a:xfrm>
           <a:prstGeom prst="rect">
@@ -4395,7 +5507,7 @@
         </p:nvSpPr>
         <p:spPr>
           <a:xfrm>
-            <a:off x="2011680" y="3108960"/>
+            <a:off x="2011680" y="2651760"/>
             <a:ext cx="8229600" cy="457200"/>
           </a:xfrm>
           <a:prstGeom prst="rect">
@@ -4410,7 +5522,7 @@
           <a:lstStyle/>
           <a:p>
             <a:pPr algn="l">
-              <a:defRPr sz="1800" b="0">
+              <a:defRPr sz="1700" b="0">
                 <a:solidFill>
                   <a:srgbClr val="666666"/>
                 </a:solidFill>
@@ -4418,7 +5530,7 @@
               </a:defRPr>
             </a:pPr>
             <a:r>
-              <a:t>The 3-parameter principle extends from elementwise to tree-structured sparsity</a:t>
+              <a:t>3-parameter principle extends from elementwise to tree-structured sparsity</a:t>
             </a:r>
           </a:p>
         </p:txBody>
@@ -4431,7 +5543,7 @@
         </p:nvSpPr>
         <p:spPr>
           <a:xfrm>
-            <a:off x="1097280" y="3977639"/>
+            <a:off x="1097280" y="3337559"/>
             <a:ext cx="548640" cy="548640"/>
           </a:xfrm>
           <a:prstGeom prst="ellipse">
@@ -4483,7 +5595,7 @@
         </p:nvSpPr>
         <p:spPr>
           <a:xfrm>
-            <a:off x="2011680" y="3931920"/>
+            <a:off x="2011680" y="3291839"/>
             <a:ext cx="8229600" cy="457200"/>
           </a:xfrm>
           <a:prstGeom prst="rect">
@@ -4519,7 +5631,7 @@
         </p:nvSpPr>
         <p:spPr>
           <a:xfrm>
-            <a:off x="2011680" y="4389120"/>
+            <a:off x="2011680" y="3703320"/>
             <a:ext cx="8229600" cy="457200"/>
           </a:xfrm>
           <a:prstGeom prst="rect">
@@ -4534,7 +5646,7 @@
           <a:lstStyle/>
           <a:p>
             <a:pPr algn="l">
-              <a:defRPr sz="1800" b="0">
+              <a:defRPr sz="1700" b="0">
                 <a:solidFill>
                   <a:srgbClr val="666666"/>
                 </a:solidFill>
@@ -4542,7 +5654,7 @@
               </a:defRPr>
             </a:pPr>
             <a:r>
-              <a:t>Simple greedy top-K tree projection nearly matches the hybrid mode</a:t>
+              <a:t>Simple greedy top-K tree projection nearly matches hybrid mode</a:t>
             </a:r>
           </a:p>
         </p:txBody>
@@ -4555,7 +5667,7 @@
         </p:nvSpPr>
         <p:spPr>
           <a:xfrm>
-            <a:off x="1097280" y="5257799"/>
+            <a:off x="1097280" y="4389120"/>
             <a:ext cx="548640" cy="548640"/>
           </a:xfrm>
           <a:prstGeom prst="ellipse">
@@ -4607,7 +5719,7 @@
         </p:nvSpPr>
         <p:spPr>
           <a:xfrm>
-            <a:off x="2011680" y="5212079"/>
+            <a:off x="2011680" y="4343400"/>
             <a:ext cx="8229600" cy="457200"/>
           </a:xfrm>
           <a:prstGeom prst="rect">
@@ -4643,7 +5755,7 @@
         </p:nvSpPr>
         <p:spPr>
           <a:xfrm>
-            <a:off x="2011680" y="5669279"/>
+            <a:off x="2011680" y="4754880"/>
             <a:ext cx="8229600" cy="457200"/>
           </a:xfrm>
           <a:prstGeom prst="rect">
@@ -4658,7 +5770,7 @@
           <a:lstStyle/>
           <a:p>
             <a:pPr algn="l">
-              <a:defRPr sz="1800" b="0">
+              <a:defRPr sz="1700" b="0">
                 <a:solidFill>
                   <a:srgbClr val="666666"/>
                 </a:solidFill>
@@ -4667,6 +5779,130 @@
             </a:pPr>
             <a:r>
               <a:t>Best SSIM on wavelet image CS at all compression ratios</a:t>
+            </a:r>
+          </a:p>
+        </p:txBody>
+      </p:sp>
+      <p:sp>
+        <p:nvSpPr>
+          <p:cNvPr id="15" name="Oval 14"/>
+          <p:cNvSpPr/>
+          <p:nvPr/>
+        </p:nvSpPr>
+        <p:spPr>
+          <a:xfrm>
+            <a:off x="1097280" y="5440679"/>
+            <a:ext cx="548640" cy="548640"/>
+          </a:xfrm>
+          <a:prstGeom prst="ellipse">
+            <a:avLst/>
+          </a:prstGeom>
+          <a:solidFill>
+            <a:srgbClr val="2E86C1"/>
+          </a:solidFill>
+          <a:ln>
+            <a:noFill/>
+          </a:ln>
+        </p:spPr>
+        <p:style>
+          <a:lnRef idx="1">
+            <a:schemeClr val="accent1"/>
+          </a:lnRef>
+          <a:fillRef idx="3">
+            <a:schemeClr val="accent1"/>
+          </a:fillRef>
+          <a:effectRef idx="2">
+            <a:schemeClr val="accent1"/>
+          </a:effectRef>
+          <a:fontRef idx="minor">
+            <a:schemeClr val="lt1"/>
+          </a:fontRef>
+        </p:style>
+        <p:txBody>
+          <a:bodyPr rtlCol="0" anchor="ctr"/>
+          <a:lstStyle/>
+          <a:p>
+            <a:pPr algn="ctr">
+              <a:defRPr sz="2200" b="1">
+                <a:solidFill>
+                  <a:srgbClr val="FFFFFF"/>
+                </a:solidFill>
+              </a:defRPr>
+            </a:pPr>
+            <a:r>
+              <a:t>5</a:t>
+            </a:r>
+          </a:p>
+        </p:txBody>
+      </p:sp>
+      <p:sp>
+        <p:nvSpPr>
+          <p:cNvPr id="16" name="TextBox 15"/>
+          <p:cNvSpPr txBox="1"/>
+          <p:nvPr/>
+        </p:nvSpPr>
+        <p:spPr>
+          <a:xfrm>
+            <a:off x="2011680" y="5394959"/>
+            <a:ext cx="8229600" cy="457200"/>
+          </a:xfrm>
+          <a:prstGeom prst="rect">
+            <a:avLst/>
+          </a:prstGeom>
+          <a:noFill/>
+        </p:spPr>
+        <p:txBody>
+          <a:bodyPr wrap="square">
+            <a:spAutoFit/>
+          </a:bodyPr>
+          <a:lstStyle/>
+          <a:p>
+            <a:pPr algn="l">
+              <a:defRPr sz="2400" b="1">
+                <a:solidFill>
+                  <a:srgbClr val="222222"/>
+                </a:solidFill>
+                <a:latin typeface="Calibri"/>
+              </a:defRPr>
+            </a:pPr>
+            <a:r>
+              <a:t>Robust &amp; Safe</a:t>
+            </a:r>
+          </a:p>
+        </p:txBody>
+      </p:sp>
+      <p:sp>
+        <p:nvSpPr>
+          <p:cNvPr id="17" name="TextBox 16"/>
+          <p:cNvSpPr txBox="1"/>
+          <p:nvPr/>
+        </p:nvSpPr>
+        <p:spPr>
+          <a:xfrm>
+            <a:off x="2011680" y="5806440"/>
+            <a:ext cx="8229600" cy="457200"/>
+          </a:xfrm>
+          <a:prstGeom prst="rect">
+            <a:avLst/>
+          </a:prstGeom>
+          <a:noFill/>
+        </p:spPr>
+        <p:txBody>
+          <a:bodyPr wrap="square">
+            <a:spAutoFit/>
+          </a:bodyPr>
+          <a:lstStyle/>
+          <a:p>
+            <a:pPr algn="l">
+              <a:defRPr sz="1700" b="0">
+                <a:solidFill>
+                  <a:srgbClr val="666666"/>
+                </a:solidFill>
+                <a:latin typeface="Calibri"/>
+              </a:defRPr>
+            </a:pPr>
+            <a:r>
+              <a:t>Graceful degradation under mismatch; doesn't hurt non-tree signals</a:t>
             </a:r>
           </a:p>
         </p:txBody>
@@ -4679,7 +5915,7 @@
 </p:sld>
 </file>
 
-<file path=ppt/slides/slide14.xml><?xml version="1.0" encoding="utf-8"?>
+<file path=ppt/slides/slide19.xml><?xml version="1.0" encoding="utf-8"?>
 <p:sld xmlns:a="http://schemas.openxmlformats.org/drawingml/2006/main" xmlns:p="http://schemas.openxmlformats.org/presentationml/2006/main" xmlns:r="http://schemas.openxmlformats.org/officeDocument/2006/relationships">
   <p:cSld>
     <p:bg>
@@ -4724,7 +5960,7 @@
                 <a:solidFill>
                   <a:srgbClr val="FFFFFF"/>
                 </a:solidFill>
-                <a:latin typeface="Calibri Light"/>
+                <a:latin typeface="Calibri"/>
               </a:defRPr>
             </a:pPr>
             <a:r>
@@ -4980,7 +6216,7 @@
               </a:defRPr>
             </a:pPr>
             <a:r>
-              <a:t>Sparse recovery: reconstruct x from y = Ax + ε</a:t>
+              <a:t>Sparse recovery: reconstruct x from y = Ax + e</a:t>
             </a:r>
           </a:p>
           <a:p>
@@ -5073,7 +6309,7 @@
               </a:defRPr>
             </a:pPr>
             <a:r>
-              <a:t>Key constraint: if a child coefficient is active,</a:t>
+              <a:t>Key constraint: if a child is active,</a:t>
             </a:r>
           </a:p>
           <a:p>
@@ -5089,7 +6325,7 @@
               </a:defRPr>
             </a:pPr>
             <a:r>
-              <a:t>its parent must also be active (tree consistency)</a:t>
+              <a:t>its parent must also be active</a:t>
             </a:r>
           </a:p>
         </p:txBody>
@@ -5378,7 +6614,7 @@
               </a:defRPr>
             </a:pPr>
             <a:r>
-              <a:t>Only 3 learned hyperparameters (c₁, c₂, c₃)</a:t>
+              <a:t>Only 3 learned hyperparameters (c1, c2, c3)</a:t>
             </a:r>
           </a:p>
           <a:p>
@@ -5455,7 +6691,7 @@
               </a:defRPr>
             </a:pPr>
             <a:r>
-              <a:t>  3. Tree scoring:   sᵢ = |uᵢ| + ρ Σ s_child  (bottom-up)</a:t>
+              <a:t>  3. Tree scoring:   si = |ui| + ρ Σ s_child</a:t>
             </a:r>
           </a:p>
           <a:p>
@@ -5487,7 +6723,7 @@
               </a:defRPr>
             </a:pPr>
             <a:r>
-              <a:t>  5. Tree threshold: soft-threshold within S, zero outside</a:t>
+              <a:t>  5. Tree threshold: soft-thresh within S</a:t>
             </a:r>
           </a:p>
           <a:p>
@@ -5516,7 +6752,7 @@
               </a:defRPr>
             </a:pPr>
             <a:r>
-              <a:t>Per-layer β, θ, K derived from (c₁, c₂, c₃)</a:t>
+              <a:t>Per-layer β, θ, K derived from (c1,c2,c3)</a:t>
             </a:r>
           </a:p>
           <a:p>
@@ -5882,7 +7118,7 @@
               </a:defRPr>
             </a:pPr>
             <a:r>
-              <a:t>   xᵢ = sign(uᵢ) max(|uᵢ| − θ, 0)</a:t>
+              <a:t>   xi = sign(ui) max(|ui| − θ, 0)</a:t>
             </a:r>
           </a:p>
           <a:p>
@@ -6184,7 +7420,7 @@
               </a:defRPr>
             </a:pPr>
             <a:r>
-              <a:t>replacing soft-threshold with tree-aware operator</a:t>
+              <a:t>replacing soft-threshold with tree operator</a:t>
             </a:r>
           </a:p>
           <a:p>
@@ -6271,7 +7507,7 @@
                 <a:solidFill>
                   <a:srgbClr val="FFFFFF"/>
                 </a:solidFill>
-                <a:latin typeface="Calibri Light"/>
+                <a:latin typeface="Calibri"/>
               </a:defRPr>
             </a:pPr>
             <a:r>
@@ -6431,7 +7667,7 @@
         </p:nvGraphicFramePr>
         <p:xfrm>
           <a:off x="914400" y="1828800"/>
-          <a:ext cx="10058400" cy="3474720"/>
+          <a:ext cx="10058400" cy="3200400"/>
         </p:xfrm>
         <a:graphic>
           <a:graphicData uri="http://schemas.openxmlformats.org/drawingml/2006/table">
@@ -6440,20 +7676,20 @@
                 <a:tableStyleId>{5C22544A-7EE6-4342-B048-85BDC9FD1C3A}</a:tableStyleId>
               </a:tblPr>
               <a:tblGrid>
-                <a:gridCol w="2560320"/>
-                <a:gridCol w="2286000"/>
-                <a:gridCol w="1645920"/>
-                <a:gridCol w="1645920"/>
-                <a:gridCol w="1920240"/>
+                <a:gridCol w="2011680"/>
+                <a:gridCol w="2011680"/>
+                <a:gridCol w="2011680"/>
+                <a:gridCol w="2011680"/>
+                <a:gridCol w="2011680"/>
               </a:tblGrid>
-              <a:tr h="496388">
+              <a:tr h="457200">
                 <a:tc>
                   <a:txBody>
                     <a:bodyPr/>
                     <a:lstStyle/>
                     <a:p>
                       <a:pPr algn="ctr">
-                        <a:defRPr sz="1600" b="1">
+                        <a:defRPr sz="1400" b="1">
                           <a:solidFill>
                             <a:srgbClr val="FFFFFF"/>
                           </a:solidFill>
@@ -6476,7 +7712,7 @@
                     <a:lstStyle/>
                     <a:p>
                       <a:pPr algn="ctr">
-                        <a:defRPr sz="1600" b="1">
+                        <a:defRPr sz="1400" b="1">
                           <a:solidFill>
                             <a:srgbClr val="FFFFFF"/>
                           </a:solidFill>
@@ -6499,7 +7735,7 @@
                     <a:lstStyle/>
                     <a:p>
                       <a:pPr algn="ctr">
-                        <a:defRPr sz="1600" b="1">
+                        <a:defRPr sz="1400" b="1">
                           <a:solidFill>
                             <a:srgbClr val="FFFFFF"/>
                           </a:solidFill>
@@ -6522,7 +7758,7 @@
                     <a:lstStyle/>
                     <a:p>
                       <a:pPr algn="ctr">
-                        <a:defRPr sz="1600" b="1">
+                        <a:defRPr sz="1400" b="1">
                           <a:solidFill>
                             <a:srgbClr val="FFFFFF"/>
                           </a:solidFill>
@@ -6545,7 +7781,7 @@
                     <a:lstStyle/>
                     <a:p>
                       <a:pPr algn="ctr">
-                        <a:defRPr sz="1600" b="1">
+                        <a:defRPr sz="1400" b="1">
                           <a:solidFill>
                             <a:srgbClr val="FFFFFF"/>
                           </a:solidFill>
@@ -6563,14 +7799,14 @@
                   </a:tcPr>
                 </a:tc>
               </a:tr>
-              <a:tr h="496388">
+              <a:tr h="457200">
                 <a:tc>
                   <a:txBody>
                     <a:bodyPr/>
                     <a:lstStyle/>
                     <a:p>
                       <a:pPr algn="ctr">
-                        <a:defRPr sz="1500" b="0">
+                        <a:defRPr sz="1300" b="0">
                           <a:solidFill>
                             <a:srgbClr val="222222"/>
                           </a:solidFill>
@@ -6593,14 +7829,14 @@
                     <a:lstStyle/>
                     <a:p>
                       <a:pPr algn="ctr">
-                        <a:defRPr sz="1500" b="0">
+                        <a:defRPr sz="1300" b="0">
                           <a:solidFill>
                             <a:srgbClr val="222222"/>
                           </a:solidFill>
                         </a:defRPr>
                       </a:pPr>
                       <a:r>
-                        <a:t>−6.00 ± 0.02</a:t>
+                        <a:t>−06.00 ± 0.02</a:t>
                       </a:r>
                     </a:p>
                   </a:txBody>
@@ -6616,7 +7852,7 @@
                     <a:lstStyle/>
                     <a:p>
                       <a:pPr algn="ctr">
-                        <a:defRPr sz="1500" b="0">
+                        <a:defRPr sz="1300" b="0">
                           <a:solidFill>
                             <a:srgbClr val="222222"/>
                           </a:solidFill>
@@ -6639,7 +7875,7 @@
                     <a:lstStyle/>
                     <a:p>
                       <a:pPr algn="ctr">
-                        <a:defRPr sz="1500" b="0">
+                        <a:defRPr sz="1300" b="0">
                           <a:solidFill>
                             <a:srgbClr val="222222"/>
                           </a:solidFill>
@@ -6662,7 +7898,7 @@
                     <a:lstStyle/>
                     <a:p>
                       <a:pPr algn="ctr">
-                        <a:defRPr sz="1500" b="0">
+                        <a:defRPr sz="1300" b="0">
                           <a:solidFill>
                             <a:srgbClr val="222222"/>
                           </a:solidFill>
@@ -6680,14 +7916,14 @@
                   </a:tcPr>
                 </a:tc>
               </a:tr>
-              <a:tr h="496388">
+              <a:tr h="457200">
                 <a:tc>
                   <a:txBody>
                     <a:bodyPr/>
                     <a:lstStyle/>
                     <a:p>
                       <a:pPr algn="ctr">
-                        <a:defRPr sz="1500" b="0">
+                        <a:defRPr sz="1300" b="0">
                           <a:solidFill>
                             <a:srgbClr val="222222"/>
                           </a:solidFill>
@@ -6710,14 +7946,14 @@
                     <a:lstStyle/>
                     <a:p>
                       <a:pPr algn="ctr">
-                        <a:defRPr sz="1500" b="0">
+                        <a:defRPr sz="1300" b="0">
                           <a:solidFill>
                             <a:srgbClr val="222222"/>
                           </a:solidFill>
                         </a:defRPr>
                       </a:pPr>
                       <a:r>
-                        <a:t>−8.34 ± 0.02</a:t>
+                        <a:t>−08.34 ± 0.02</a:t>
                       </a:r>
                     </a:p>
                   </a:txBody>
@@ -6733,7 +7969,7 @@
                     <a:lstStyle/>
                     <a:p>
                       <a:pPr algn="ctr">
-                        <a:defRPr sz="1500" b="0">
+                        <a:defRPr sz="1300" b="0">
                           <a:solidFill>
                             <a:srgbClr val="222222"/>
                           </a:solidFill>
@@ -6756,7 +7992,7 @@
                     <a:lstStyle/>
                     <a:p>
                       <a:pPr algn="ctr">
-                        <a:defRPr sz="1500" b="0">
+                        <a:defRPr sz="1300" b="0">
                           <a:solidFill>
                             <a:srgbClr val="222222"/>
                           </a:solidFill>
@@ -6779,7 +8015,7 @@
                     <a:lstStyle/>
                     <a:p>
                       <a:pPr algn="ctr">
-                        <a:defRPr sz="1500" b="0">
+                        <a:defRPr sz="1300" b="0">
                           <a:solidFill>
                             <a:srgbClr val="222222"/>
                           </a:solidFill>
@@ -6797,14 +8033,14 @@
                   </a:tcPr>
                 </a:tc>
               </a:tr>
-              <a:tr h="496388">
+              <a:tr h="457200">
                 <a:tc>
                   <a:txBody>
                     <a:bodyPr/>
                     <a:lstStyle/>
                     <a:p>
                       <a:pPr algn="ctr">
-                        <a:defRPr sz="1500" b="0">
+                        <a:defRPr sz="1300" b="0">
                           <a:solidFill>
                             <a:srgbClr val="222222"/>
                           </a:solidFill>
@@ -6827,7 +8063,7 @@
                     <a:lstStyle/>
                     <a:p>
                       <a:pPr algn="ctr">
-                        <a:defRPr sz="1500" b="0">
+                        <a:defRPr sz="1300" b="0">
                           <a:solidFill>
                             <a:srgbClr val="222222"/>
                           </a:solidFill>
@@ -6850,7 +8086,7 @@
                     <a:lstStyle/>
                     <a:p>
                       <a:pPr algn="ctr">
-                        <a:defRPr sz="1500" b="0">
+                        <a:defRPr sz="1300" b="0">
                           <a:solidFill>
                             <a:srgbClr val="222222"/>
                           </a:solidFill>
@@ -6873,7 +8109,7 @@
                     <a:lstStyle/>
                     <a:p>
                       <a:pPr algn="ctr">
-                        <a:defRPr sz="1500" b="0">
+                        <a:defRPr sz="1300" b="0">
                           <a:solidFill>
                             <a:srgbClr val="222222"/>
                           </a:solidFill>
@@ -6896,7 +8132,7 @@
                     <a:lstStyle/>
                     <a:p>
                       <a:pPr algn="ctr">
-                        <a:defRPr sz="1500" b="0">
+                        <a:defRPr sz="1300" b="0">
                           <a:solidFill>
                             <a:srgbClr val="222222"/>
                           </a:solidFill>
@@ -6914,14 +8150,14 @@
                   </a:tcPr>
                 </a:tc>
               </a:tr>
-              <a:tr h="496388">
+              <a:tr h="457200">
                 <a:tc>
                   <a:txBody>
                     <a:bodyPr/>
                     <a:lstStyle/>
                     <a:p>
                       <a:pPr algn="ctr">
-                        <a:defRPr sz="1500" b="0">
+                        <a:defRPr sz="1300" b="0">
                           <a:solidFill>
                             <a:srgbClr val="222222"/>
                           </a:solidFill>
@@ -6944,7 +8180,7 @@
                     <a:lstStyle/>
                     <a:p>
                       <a:pPr algn="ctr">
-                        <a:defRPr sz="1500" b="0">
+                        <a:defRPr sz="1300" b="0">
                           <a:solidFill>
                             <a:srgbClr val="222222"/>
                           </a:solidFill>
@@ -6967,7 +8203,7 @@
                     <a:lstStyle/>
                     <a:p>
                       <a:pPr algn="ctr">
-                        <a:defRPr sz="1500" b="0">
+                        <a:defRPr sz="1300" b="0">
                           <a:solidFill>
                             <a:srgbClr val="222222"/>
                           </a:solidFill>
@@ -6990,7 +8226,7 @@
                     <a:lstStyle/>
                     <a:p>
                       <a:pPr algn="ctr">
-                        <a:defRPr sz="1500" b="0">
+                        <a:defRPr sz="1300" b="0">
                           <a:solidFill>
                             <a:srgbClr val="222222"/>
                           </a:solidFill>
@@ -7013,7 +8249,7 @@
                     <a:lstStyle/>
                     <a:p>
                       <a:pPr algn="ctr">
-                        <a:defRPr sz="1500" b="0">
+                        <a:defRPr sz="1300" b="0">
                           <a:solidFill>
                             <a:srgbClr val="222222"/>
                           </a:solidFill>
@@ -7031,14 +8267,14 @@
                   </a:tcPr>
                 </a:tc>
               </a:tr>
-              <a:tr h="496388">
+              <a:tr h="457200">
                 <a:tc>
                   <a:txBody>
                     <a:bodyPr/>
                     <a:lstStyle/>
                     <a:p>
                       <a:pPr algn="ctr">
-                        <a:defRPr sz="1500" b="1">
+                        <a:defRPr sz="1300" b="1">
                           <a:solidFill>
                             <a:srgbClr val="1D8D48"/>
                           </a:solidFill>
@@ -7061,7 +8297,7 @@
                     <a:lstStyle/>
                     <a:p>
                       <a:pPr algn="ctr">
-                        <a:defRPr sz="1500" b="1">
+                        <a:defRPr sz="1300" b="1">
                           <a:solidFill>
                             <a:srgbClr val="1D8D48"/>
                           </a:solidFill>
@@ -7084,7 +8320,7 @@
                     <a:lstStyle/>
                     <a:p>
                       <a:pPr algn="ctr">
-                        <a:defRPr sz="1500" b="1">
+                        <a:defRPr sz="1300" b="1">
                           <a:solidFill>
                             <a:srgbClr val="1D8D48"/>
                           </a:solidFill>
@@ -7107,7 +8343,7 @@
                     <a:lstStyle/>
                     <a:p>
                       <a:pPr algn="ctr">
-                        <a:defRPr sz="1500" b="1">
+                        <a:defRPr sz="1300" b="1">
                           <a:solidFill>
                             <a:srgbClr val="1D8D48"/>
                           </a:solidFill>
@@ -7130,7 +8366,7 @@
                     <a:lstStyle/>
                     <a:p>
                       <a:pPr algn="ctr">
-                        <a:defRPr sz="1500" b="1">
+                        <a:defRPr sz="1300" b="1">
                           <a:solidFill>
                             <a:srgbClr val="1D8D48"/>
                           </a:solidFill>
@@ -7148,14 +8384,14 @@
                   </a:tcPr>
                 </a:tc>
               </a:tr>
-              <a:tr h="496392">
+              <a:tr h="457200">
                 <a:tc>
                   <a:txBody>
                     <a:bodyPr/>
                     <a:lstStyle/>
                     <a:p>
                       <a:pPr algn="ctr">
-                        <a:defRPr sz="1500" b="1">
+                        <a:defRPr sz="1300" b="1">
                           <a:solidFill>
                             <a:srgbClr val="1D8D48"/>
                           </a:solidFill>
@@ -7178,7 +8414,7 @@
                     <a:lstStyle/>
                     <a:p>
                       <a:pPr algn="ctr">
-                        <a:defRPr sz="1500" b="1">
+                        <a:defRPr sz="1300" b="1">
                           <a:solidFill>
                             <a:srgbClr val="1D8D48"/>
                           </a:solidFill>
@@ -7201,7 +8437,7 @@
                     <a:lstStyle/>
                     <a:p>
                       <a:pPr algn="ctr">
-                        <a:defRPr sz="1500" b="1">
+                        <a:defRPr sz="1300" b="1">
                           <a:solidFill>
                             <a:srgbClr val="1D8D48"/>
                           </a:solidFill>
@@ -7224,7 +8460,7 @@
                     <a:lstStyle/>
                     <a:p>
                       <a:pPr algn="ctr">
-                        <a:defRPr sz="1500" b="1">
+                        <a:defRPr sz="1300" b="1">
                           <a:solidFill>
                             <a:srgbClr val="1D8D48"/>
                           </a:solidFill>
@@ -7247,7 +8483,7 @@
                     <a:lstStyle/>
                     <a:p>
                       <a:pPr algn="ctr">
-                        <a:defRPr sz="1500" b="1">
+                        <a:defRPr sz="1300" b="1">
                           <a:solidFill>
                             <a:srgbClr val="1D8D48"/>
                           </a:solidFill>
@@ -7277,7 +8513,7 @@
         </p:nvSpPr>
         <p:spPr>
           <a:xfrm>
-            <a:off x="914400" y="5486400"/>
+            <a:off x="914400" y="5303520"/>
             <a:ext cx="10058400" cy="1097280"/>
           </a:xfrm>
           <a:prstGeom prst="rect">
@@ -7303,7 +8539,7 @@
               </a:defRPr>
             </a:pPr>
             <a:r>
-              <a:t>TH-Hybrid: +12.8 dB over HyperLISTA (same 3 params)  |  +15.5 dB over LISTA (1.56M params)  |  Perfect recall (1.000)</a:t>
+              <a:t>TH-Hybrid: +12.8 dB over HyperLISTA (same 3 params)  |  +15.5 dB over LISTA (1.56M params)  |  Perfect recall</a:t>
             </a:r>
           </a:p>
         </p:txBody>
@@ -7681,7 +8917,7 @@
               </a:defRPr>
             </a:pPr>
             <a:r>
-              <a:t>Tree-HyperLISTA degrades gracefully under SNR variation and sparsity mismatch</a:t>
+              <a:t>Tree-HyperLISTA degrades gracefully under SNR and sparsity mismatch</a:t>
             </a:r>
           </a:p>
         </p:txBody>
@@ -7873,7 +9109,7 @@
               </a:defRPr>
             </a:pPr>
             <a:r>
-              <a:t>Sensitivity: broad optimal basin for c₂ (momentum); c₁ (threshold) most critical</a:t>
+              <a:t>Sensitivity: broad optimal basin for c2 (momentum); c1 (threshold) most critical</a:t>
             </a:r>
           </a:p>
           <a:p>
@@ -7889,7 +9125,7 @@
               </a:defRPr>
             </a:pPr>
             <a:r>
-              <a:t>Mechanisms: M1 (hard) and M3 (hybrid) perform comparably; M2 (threshold) unstable</a:t>
+              <a:t>Mechanisms: M1 (hard) and M3 (hybrid) comparable; M2 (threshold) unstable</a:t>
             </a:r>
           </a:p>
         </p:txBody>

</xml_diff>